<commit_message>
Remove egg watermark from Mito Colesterol
</commit_message>
<xml_diff>
--- a/Dia-5/Carrusel Mito Colesterol - FB 1080x1080.pptx
+++ b/Dia-5/Carrusel Mito Colesterol - FB 1080x1080.pptx
@@ -3102,22 +3102,22 @@
       <p:grpSpPr/>
       <p:sp>
         <p:nvSpPr>
-          <p:cNvPr id="2" name="Oval 1"/>
+          <p:cNvPr id="2" name="Rounded Rectangle 1"/>
           <p:cNvSpPr/>
           <p:nvPr/>
         </p:nvSpPr>
         <p:spPr>
           <a:xfrm>
-            <a:off x="4518051" y="2874172"/>
-            <a:ext cx="6748272" cy="8637788"/>
+            <a:off x="777240" y="777240"/>
+            <a:ext cx="2521458" cy="373380"/>
           </a:xfrm>
-          <a:prstGeom prst="ellipse">
-            <a:avLst/>
+          <a:prstGeom prst="roundRect">
+            <a:avLst>
+              <a:gd name="adj" fmla="val 50000"/>
+            </a:avLst>
           </a:prstGeom>
           <a:solidFill>
-            <a:srgbClr val="14181F">
-              <a:alpha val="16000"/>
-            </a:srgbClr>
+            <a:srgbClr val="14181F"/>
           </a:solidFill>
           <a:ln>
             <a:noFill/>
@@ -3139,61 +3139,31 @@
           </a:fontRef>
         </p:style>
         <p:txBody>
-          <a:bodyPr rtlCol="0" anchor="ctr"/>
+          <a:bodyPr rtlCol="0" anchor="ctr" wrap="none" lIns="128016" rIns="128016" tIns="18288" bIns="18288"/>
           <a:lstStyle/>
           <a:p>
             <a:pPr algn="ctr"/>
-          </a:p>
-        </p:txBody>
-      </p:sp>
-      <p:sp>
-        <p:nvSpPr>
-          <p:cNvPr id="3" name="TextBox 2"/>
-          <p:cNvSpPr txBox="1"/>
+            <a:r>
+              <a:rPr sz="1500" b="1">
+                <a:solidFill>
+                  <a:srgbClr val="F5C13F"/>
+                </a:solidFill>
+                <a:latin typeface="Bricolage Grotesque"/>
+              </a:rPr>
+              <a:t>MITO VS. REALIDAD</a:t>
+            </a:r>
+          </a:p>
+        </p:txBody>
+      </p:sp>
+      <p:sp>
+        <p:nvSpPr>
+          <p:cNvPr id="3" name="Rectangle 2"/>
+          <p:cNvSpPr/>
           <p:nvPr/>
         </p:nvSpPr>
         <p:spPr>
           <a:xfrm>
-            <a:off x="777240" y="777240"/>
-            <a:ext cx="6675120" cy="457200"/>
-          </a:xfrm>
-          <a:prstGeom prst="rect">
-            <a:avLst/>
-          </a:prstGeom>
-          <a:noFill/>
-        </p:spPr>
-        <p:txBody>
-          <a:bodyPr wrap="square" anchor="t" lIns="0" rIns="0" tIns="0" bIns="0">
-            <a:spAutoFit/>
-          </a:bodyPr>
-          <a:lstStyle/>
-          <a:p>
-            <a:pPr algn="l">
-              <a:lnSpc>
-                <a:spcPct val="100000"/>
-              </a:lnSpc>
-            </a:pPr>
-            <a:r>
-              <a:rPr sz="1800" b="1">
-                <a:solidFill>
-                  <a:srgbClr val="14181F"/>
-                </a:solidFill>
-                <a:latin typeface="Hanken Grotesk"/>
-              </a:rPr>
-              <a:t>MITO VS. REALIDAD</a:t>
-            </a:r>
-          </a:p>
-        </p:txBody>
-      </p:sp>
-      <p:sp>
-        <p:nvSpPr>
-          <p:cNvPr id="4" name="Rectangle 3"/>
-          <p:cNvSpPr/>
-          <p:nvPr/>
-        </p:nvSpPr>
-        <p:spPr>
-          <a:xfrm>
-            <a:off x="777240" y="1280160"/>
+            <a:off x="777240" y="1764411"/>
             <a:ext cx="1371600" cy="146304"/>
           </a:xfrm>
           <a:prstGeom prst="rect">
@@ -3231,14 +3201,14 @@
       </p:sp>
       <p:sp>
         <p:nvSpPr>
-          <p:cNvPr id="5" name="TextBox 4"/>
+          <p:cNvPr id="4" name="TextBox 3"/>
           <p:cNvSpPr txBox="1"/>
           <p:nvPr/>
         </p:nvSpPr>
         <p:spPr>
           <a:xfrm>
-            <a:off x="777240" y="1737360"/>
-            <a:ext cx="6675120" cy="4991608"/>
+            <a:off x="777240" y="2221611"/>
+            <a:ext cx="6675120" cy="3054858"/>
           </a:xfrm>
           <a:prstGeom prst="rect">
             <a:avLst/>
@@ -3257,7 +3227,7 @@
               </a:lnSpc>
             </a:pPr>
             <a:r>
-              <a:rPr sz="7400" b="1">
+              <a:rPr sz="5800" b="1">
                 <a:solidFill>
                   <a:srgbClr val="14181F"/>
                 </a:solidFill>
@@ -3270,13 +3240,13 @@
       </p:sp>
       <p:sp>
         <p:nvSpPr>
-          <p:cNvPr id="6" name="TextBox 5"/>
+          <p:cNvPr id="5" name="TextBox 4"/>
           <p:cNvSpPr txBox="1"/>
           <p:nvPr/>
         </p:nvSpPr>
         <p:spPr>
           <a:xfrm>
-            <a:off x="777240" y="5877052"/>
+            <a:off x="777240" y="5276469"/>
             <a:ext cx="6675120" cy="1118108"/>
           </a:xfrm>
           <a:prstGeom prst="rect">
@@ -3309,7 +3279,7 @@
       </p:sp>
       <p:sp>
         <p:nvSpPr>
-          <p:cNvPr id="7" name="TextBox 6"/>
+          <p:cNvPr id="6" name="TextBox 5"/>
           <p:cNvSpPr txBox="1"/>
           <p:nvPr/>
         </p:nvSpPr>
@@ -3357,7 +3327,7 @@
       </p:sp>
       <p:sp>
         <p:nvSpPr>
-          <p:cNvPr id="8" name="TextBox 7"/>
+          <p:cNvPr id="7" name="TextBox 6"/>
           <p:cNvSpPr txBox="1"/>
           <p:nvPr/>
         </p:nvSpPr>
@@ -3422,52 +3392,112 @@
       <p:grpSpPr/>
       <p:sp>
         <p:nvSpPr>
-          <p:cNvPr id="2" name="TextBox 1"/>
-          <p:cNvSpPr txBox="1"/>
+          <p:cNvPr id="2" name="Rounded Rectangle 1"/>
+          <p:cNvSpPr/>
           <p:nvPr/>
         </p:nvSpPr>
         <p:spPr>
           <a:xfrm>
             <a:off x="777240" y="777240"/>
-            <a:ext cx="6675120" cy="457200"/>
+            <a:ext cx="1264158" cy="373380"/>
+          </a:xfrm>
+          <a:prstGeom prst="roundRect">
+            <a:avLst>
+              <a:gd name="adj" fmla="val 50000"/>
+            </a:avLst>
+          </a:prstGeom>
+          <a:solidFill>
+            <a:srgbClr val="F5C13F"/>
+          </a:solidFill>
+          <a:ln>
+            <a:noFill/>
+          </a:ln>
+          <a:effectLst/>
+        </p:spPr>
+        <p:style>
+          <a:lnRef idx="1">
+            <a:schemeClr val="accent1"/>
+          </a:lnRef>
+          <a:fillRef idx="3">
+            <a:schemeClr val="accent1"/>
+          </a:fillRef>
+          <a:effectRef idx="2">
+            <a:schemeClr val="accent1"/>
+          </a:effectRef>
+          <a:fontRef idx="minor">
+            <a:schemeClr val="lt1"/>
+          </a:fontRef>
+        </p:style>
+        <p:txBody>
+          <a:bodyPr rtlCol="0" anchor="ctr" wrap="none" lIns="128016" rIns="128016" tIns="18288" bIns="18288"/>
+          <a:lstStyle/>
+          <a:p>
+            <a:pPr algn="ctr"/>
+            <a:r>
+              <a:rPr sz="1500" b="1">
+                <a:solidFill>
+                  <a:srgbClr val="14181F"/>
+                </a:solidFill>
+                <a:latin typeface="Bricolage Grotesque"/>
+              </a:rPr>
+              <a:t>EL MITO</a:t>
+            </a:r>
+          </a:p>
+        </p:txBody>
+      </p:sp>
+      <p:sp>
+        <p:nvSpPr>
+          <p:cNvPr id="3" name="Rectangle 2"/>
+          <p:cNvSpPr/>
+          <p:nvPr/>
+        </p:nvSpPr>
+        <p:spPr>
+          <a:xfrm>
+            <a:off x="777240" y="1621536"/>
+            <a:ext cx="1371600" cy="146304"/>
           </a:xfrm>
           <a:prstGeom prst="rect">
             <a:avLst/>
           </a:prstGeom>
-          <a:noFill/>
+          <a:solidFill>
+            <a:srgbClr val="F5C13F"/>
+          </a:solidFill>
+          <a:ln>
+            <a:noFill/>
+          </a:ln>
+          <a:effectLst/>
         </p:spPr>
-        <p:txBody>
-          <a:bodyPr wrap="square" anchor="t" lIns="0" rIns="0" tIns="0" bIns="0">
-            <a:spAutoFit/>
-          </a:bodyPr>
-          <a:lstStyle/>
-          <a:p>
-            <a:pPr algn="l">
-              <a:lnSpc>
-                <a:spcPct val="100000"/>
-              </a:lnSpc>
-            </a:pPr>
-            <a:r>
-              <a:rPr sz="1800" b="1">
-                <a:solidFill>
-                  <a:srgbClr val="F5C13F"/>
-                </a:solidFill>
-                <a:latin typeface="Hanken Grotesk"/>
-              </a:rPr>
-              <a:t>EL MITO</a:t>
-            </a:r>
-          </a:p>
-        </p:txBody>
-      </p:sp>
-      <p:sp>
-        <p:nvSpPr>
-          <p:cNvPr id="3" name="TextBox 2"/>
+        <p:style>
+          <a:lnRef idx="1">
+            <a:schemeClr val="accent1"/>
+          </a:lnRef>
+          <a:fillRef idx="3">
+            <a:schemeClr val="accent1"/>
+          </a:fillRef>
+          <a:effectRef idx="2">
+            <a:schemeClr val="accent1"/>
+          </a:effectRef>
+          <a:fontRef idx="minor">
+            <a:schemeClr val="lt1"/>
+          </a:fontRef>
+        </p:style>
+        <p:txBody>
+          <a:bodyPr rtlCol="0" anchor="ctr"/>
+          <a:lstStyle/>
+          <a:p>
+            <a:pPr algn="ctr"/>
+          </a:p>
+        </p:txBody>
+      </p:sp>
+      <p:sp>
+        <p:nvSpPr>
+          <p:cNvPr id="4" name="TextBox 3"/>
           <p:cNvSpPr txBox="1"/>
           <p:nvPr/>
         </p:nvSpPr>
         <p:spPr>
           <a:xfrm>
-            <a:off x="777240" y="1417320"/>
+            <a:off x="777240" y="2078736"/>
             <a:ext cx="6675120" cy="3340608"/>
           </a:xfrm>
           <a:prstGeom prst="rect">
@@ -3500,14 +3530,14 @@
       </p:sp>
       <p:sp>
         <p:nvSpPr>
-          <p:cNvPr id="4" name="TextBox 3"/>
+          <p:cNvPr id="5" name="TextBox 4"/>
           <p:cNvSpPr txBox="1"/>
           <p:nvPr/>
         </p:nvSpPr>
         <p:spPr>
           <a:xfrm>
-            <a:off x="777240" y="4757928"/>
-            <a:ext cx="6675120" cy="835660"/>
+            <a:off x="777240" y="5419344"/>
+            <a:ext cx="6675120" cy="1530858"/>
           </a:xfrm>
           <a:prstGeom prst="rect">
             <a:avLst/>
@@ -3526,13 +3556,13 @@
               </a:lnSpc>
             </a:pPr>
             <a:r>
-              <a:rPr sz="2200" b="0">
+              <a:rPr sz="2600" b="0">
                 <a:solidFill>
                   <a:srgbClr val="FFFFFF"/>
                 </a:solidFill>
                 <a:latin typeface="Hanken Grotesk"/>
               </a:rPr>
-              <a:t>"No comas tantos a la semana", decían.</a:t>
+              <a:t>“No comas tantos a la semana”, decían.</a:t>
             </a:r>
           </a:p>
         </p:txBody>
@@ -3565,14 +3595,113 @@
       <p:grpSpPr/>
       <p:sp>
         <p:nvSpPr>
-          <p:cNvPr id="2" name="TextBox 1"/>
+          <p:cNvPr id="2" name="Rounded Rectangle 1"/>
+          <p:cNvSpPr/>
+          <p:nvPr/>
+        </p:nvSpPr>
+        <p:spPr>
+          <a:xfrm>
+            <a:off x="777240" y="777240"/>
+            <a:ext cx="1767078" cy="373380"/>
+          </a:xfrm>
+          <a:prstGeom prst="roundRect">
+            <a:avLst>
+              <a:gd name="adj" fmla="val 50000"/>
+            </a:avLst>
+          </a:prstGeom>
+          <a:solidFill>
+            <a:srgbClr val="F5C13F"/>
+          </a:solidFill>
+          <a:ln>
+            <a:noFill/>
+          </a:ln>
+          <a:effectLst/>
+        </p:spPr>
+        <p:style>
+          <a:lnRef idx="1">
+            <a:schemeClr val="accent1"/>
+          </a:lnRef>
+          <a:fillRef idx="3">
+            <a:schemeClr val="accent1"/>
+          </a:fillRef>
+          <a:effectRef idx="2">
+            <a:schemeClr val="accent1"/>
+          </a:effectRef>
+          <a:fontRef idx="minor">
+            <a:schemeClr val="lt1"/>
+          </a:fontRef>
+        </p:style>
+        <p:txBody>
+          <a:bodyPr rtlCol="0" anchor="ctr" wrap="none" lIns="128016" rIns="128016" tIns="18288" bIns="18288"/>
+          <a:lstStyle/>
+          <a:p>
+            <a:pPr algn="ctr"/>
+            <a:r>
+              <a:rPr sz="1500" b="1">
+                <a:solidFill>
+                  <a:srgbClr val="14181F"/>
+                </a:solidFill>
+                <a:latin typeface="Bricolage Grotesque"/>
+              </a:rPr>
+              <a:t>LA REALIDAD</a:t>
+            </a:r>
+          </a:p>
+        </p:txBody>
+      </p:sp>
+      <p:sp>
+        <p:nvSpPr>
+          <p:cNvPr id="3" name="Rectangle 2"/>
+          <p:cNvSpPr/>
+          <p:nvPr/>
+        </p:nvSpPr>
+        <p:spPr>
+          <a:xfrm>
+            <a:off x="777240" y="1637411"/>
+            <a:ext cx="1371600" cy="146304"/>
+          </a:xfrm>
+          <a:prstGeom prst="rect">
+            <a:avLst/>
+          </a:prstGeom>
+          <a:solidFill>
+            <a:srgbClr val="F5C13F"/>
+          </a:solidFill>
+          <a:ln>
+            <a:noFill/>
+          </a:ln>
+          <a:effectLst/>
+        </p:spPr>
+        <p:style>
+          <a:lnRef idx="1">
+            <a:schemeClr val="accent1"/>
+          </a:lnRef>
+          <a:fillRef idx="3">
+            <a:schemeClr val="accent1"/>
+          </a:fillRef>
+          <a:effectRef idx="2">
+            <a:schemeClr val="accent1"/>
+          </a:effectRef>
+          <a:fontRef idx="minor">
+            <a:schemeClr val="lt1"/>
+          </a:fontRef>
+        </p:style>
+        <p:txBody>
+          <a:bodyPr rtlCol="0" anchor="ctr"/>
+          <a:lstStyle/>
+          <a:p>
+            <a:pPr algn="ctr"/>
+          </a:p>
+        </p:txBody>
+      </p:sp>
+      <p:sp>
+        <p:nvSpPr>
+          <p:cNvPr id="4" name="TextBox 3"/>
           <p:cNvSpPr txBox="1"/>
           <p:nvPr/>
         </p:nvSpPr>
         <p:spPr>
           <a:xfrm>
-            <a:off x="777240" y="1743456"/>
-            <a:ext cx="6675120" cy="457200"/>
+            <a:off x="777240" y="2094611"/>
+            <a:ext cx="6675120" cy="3308858"/>
           </a:xfrm>
           <a:prstGeom prst="rect">
             <a:avLst/>
@@ -3585,52 +3714,13 @@
           </a:bodyPr>
           <a:lstStyle/>
           <a:p>
-            <a:pPr algn="ctr">
+            <a:pPr algn="l">
               <a:lnSpc>
                 <a:spcPct val="100000"/>
               </a:lnSpc>
             </a:pPr>
             <a:r>
-              <a:rPr sz="1800" b="1">
-                <a:solidFill>
-                  <a:srgbClr val="F5C13F"/>
-                </a:solidFill>
-                <a:latin typeface="Hanken Grotesk"/>
-              </a:rPr>
-              <a:t>LA REALIDAD</a:t>
-            </a:r>
-          </a:p>
-        </p:txBody>
-      </p:sp>
-      <p:sp>
-        <p:nvSpPr>
-          <p:cNvPr id="3" name="TextBox 2"/>
-          <p:cNvSpPr txBox="1"/>
-          <p:nvPr/>
-        </p:nvSpPr>
-        <p:spPr>
-          <a:xfrm>
-            <a:off x="777240" y="2383536"/>
-            <a:ext cx="6675120" cy="4102608"/>
-          </a:xfrm>
-          <a:prstGeom prst="rect">
-            <a:avLst/>
-          </a:prstGeom>
-          <a:noFill/>
-        </p:spPr>
-        <p:txBody>
-          <a:bodyPr wrap="square" anchor="t" lIns="0" rIns="0" tIns="0" bIns="0">
-            <a:spAutoFit/>
-          </a:bodyPr>
-          <a:lstStyle/>
-          <a:p>
-            <a:pPr algn="ctr">
-              <a:lnSpc>
-                <a:spcPct val="100000"/>
-              </a:lnSpc>
-            </a:pPr>
-            <a:r>
-              <a:rPr sz="4000" b="1">
+              <a:rPr sz="3800" b="1">
                 <a:solidFill>
                   <a:srgbClr val="14181F"/>
                 </a:solidFill>
@@ -3669,14 +3759,113 @@
       <p:grpSpPr/>
       <p:sp>
         <p:nvSpPr>
-          <p:cNvPr id="2" name="TextBox 1"/>
-          <p:cNvSpPr txBox="1"/>
+          <p:cNvPr id="2" name="Rounded Rectangle 1"/>
+          <p:cNvSpPr/>
           <p:nvPr/>
         </p:nvSpPr>
         <p:spPr>
           <a:xfrm>
             <a:off x="777240" y="777240"/>
-            <a:ext cx="6675120" cy="457200"/>
+            <a:ext cx="1515618" cy="373380"/>
+          </a:xfrm>
+          <a:prstGeom prst="roundRect">
+            <a:avLst>
+              <a:gd name="adj" fmla="val 50000"/>
+            </a:avLst>
+          </a:prstGeom>
+          <a:solidFill>
+            <a:srgbClr val="F5C13F"/>
+          </a:solidFill>
+          <a:ln>
+            <a:noFill/>
+          </a:ln>
+          <a:effectLst/>
+        </p:spPr>
+        <p:style>
+          <a:lnRef idx="1">
+            <a:schemeClr val="accent1"/>
+          </a:lnRef>
+          <a:fillRef idx="3">
+            <a:schemeClr val="accent1"/>
+          </a:fillRef>
+          <a:effectRef idx="2">
+            <a:schemeClr val="accent1"/>
+          </a:effectRef>
+          <a:fontRef idx="minor">
+            <a:schemeClr val="lt1"/>
+          </a:fontRef>
+        </p:style>
+        <p:txBody>
+          <a:bodyPr rtlCol="0" anchor="ctr" wrap="none" lIns="128016" rIns="128016" tIns="18288" bIns="18288"/>
+          <a:lstStyle/>
+          <a:p>
+            <a:pPr algn="ctr"/>
+            <a:r>
+              <a:rPr sz="1500" b="1">
+                <a:solidFill>
+                  <a:srgbClr val="14181F"/>
+                </a:solidFill>
+                <a:latin typeface="Bricolage Grotesque"/>
+              </a:rPr>
+              <a:t>ENTONCES…</a:t>
+            </a:r>
+          </a:p>
+        </p:txBody>
+      </p:sp>
+      <p:sp>
+        <p:nvSpPr>
+          <p:cNvPr id="3" name="Rectangle 2"/>
+          <p:cNvSpPr/>
+          <p:nvPr/>
+        </p:nvSpPr>
+        <p:spPr>
+          <a:xfrm>
+            <a:off x="777240" y="1478661"/>
+            <a:ext cx="1371600" cy="146304"/>
+          </a:xfrm>
+          <a:prstGeom prst="rect">
+            <a:avLst/>
+          </a:prstGeom>
+          <a:solidFill>
+            <a:srgbClr val="F5C13F"/>
+          </a:solidFill>
+          <a:ln>
+            <a:noFill/>
+          </a:ln>
+          <a:effectLst/>
+        </p:spPr>
+        <p:style>
+          <a:lnRef idx="1">
+            <a:schemeClr val="accent1"/>
+          </a:lnRef>
+          <a:fillRef idx="3">
+            <a:schemeClr val="accent1"/>
+          </a:fillRef>
+          <a:effectRef idx="2">
+            <a:schemeClr val="accent1"/>
+          </a:effectRef>
+          <a:fontRef idx="minor">
+            <a:schemeClr val="lt1"/>
+          </a:fontRef>
+        </p:style>
+        <p:txBody>
+          <a:bodyPr rtlCol="0" anchor="ctr"/>
+          <a:lstStyle/>
+          <a:p>
+            <a:pPr algn="ctr"/>
+          </a:p>
+        </p:txBody>
+      </p:sp>
+      <p:sp>
+        <p:nvSpPr>
+          <p:cNvPr id="4" name="TextBox 3"/>
+          <p:cNvSpPr txBox="1"/>
+          <p:nvPr/>
+        </p:nvSpPr>
+        <p:spPr>
+          <a:xfrm>
+            <a:off x="777240" y="1935861"/>
+            <a:ext cx="6675120" cy="3626358"/>
           </a:xfrm>
           <a:prstGeom prst="rect">
             <a:avLst/>
@@ -3695,27 +3884,27 @@
               </a:lnSpc>
             </a:pPr>
             <a:r>
-              <a:rPr sz="1800" b="1">
+              <a:rPr sz="4200" b="1">
                 <a:solidFill>
-                  <a:srgbClr val="F5C13F"/>
+                  <a:srgbClr val="FFFFFF"/>
                 </a:solidFill>
-                <a:latin typeface="Hanken Grotesk"/>
+                <a:latin typeface="Bricolage Grotesque"/>
               </a:rPr>
-              <a:t>ENTONCES…</a:t>
-            </a:r>
-          </a:p>
-        </p:txBody>
-      </p:sp>
-      <p:sp>
-        <p:nvSpPr>
-          <p:cNvPr id="3" name="TextBox 2"/>
+              <a:t>Para la mayoría sana, un huevo al día cabe en una dieta equilibrada.</a:t>
+            </a:r>
+          </a:p>
+        </p:txBody>
+      </p:sp>
+      <p:sp>
+        <p:nvSpPr>
+          <p:cNvPr id="5" name="TextBox 4"/>
           <p:cNvSpPr txBox="1"/>
           <p:nvPr/>
         </p:nvSpPr>
         <p:spPr>
           <a:xfrm>
-            <a:off x="777240" y="1417320"/>
-            <a:ext cx="6675120" cy="3467608"/>
+            <a:off x="777240" y="5464302"/>
+            <a:ext cx="6675120" cy="1530858"/>
           </a:xfrm>
           <a:prstGeom prst="rect">
             <a:avLst/>
@@ -3730,50 +3919,11 @@
           <a:p>
             <a:pPr algn="l">
               <a:lnSpc>
-                <a:spcPct val="100000"/>
-              </a:lnSpc>
-            </a:pPr>
-            <a:r>
-              <a:rPr sz="4000" b="1">
-                <a:solidFill>
-                  <a:srgbClr val="FFFFFF"/>
-                </a:solidFill>
-                <a:latin typeface="Bricolage Grotesque"/>
-              </a:rPr>
-              <a:t>Para la mayoría de personas sanas, un huevo al día cabe en una dieta equilibrada.</a:t>
-            </a:r>
-          </a:p>
-        </p:txBody>
-      </p:sp>
-      <p:sp>
-        <p:nvSpPr>
-          <p:cNvPr id="4" name="TextBox 3"/>
-          <p:cNvSpPr txBox="1"/>
-          <p:nvPr/>
-        </p:nvSpPr>
-        <p:spPr>
-          <a:xfrm>
-            <a:off x="777240" y="4884928"/>
-            <a:ext cx="6675120" cy="1184909"/>
-          </a:xfrm>
-          <a:prstGeom prst="rect">
-            <a:avLst/>
-          </a:prstGeom>
-          <a:noFill/>
-        </p:spPr>
-        <p:txBody>
-          <a:bodyPr wrap="square" anchor="t" lIns="0" rIns="0" tIns="0" bIns="0">
-            <a:spAutoFit/>
-          </a:bodyPr>
-          <a:lstStyle/>
-          <a:p>
-            <a:pPr algn="l">
-              <a:lnSpc>
                 <a:spcPct val="110000"/>
               </a:lnSpc>
             </a:pPr>
             <a:r>
-              <a:rPr sz="2200" b="0">
+              <a:rPr sz="2600" b="0">
                 <a:solidFill>
                   <a:srgbClr val="FFFFFF"/>
                 </a:solidFill>
@@ -3812,22 +3962,22 @@
       <p:grpSpPr/>
       <p:sp>
         <p:nvSpPr>
-          <p:cNvPr id="2" name="Oval 1"/>
+          <p:cNvPr id="2" name="Rounded Rectangle 1"/>
           <p:cNvSpPr/>
           <p:nvPr/>
         </p:nvSpPr>
         <p:spPr>
           <a:xfrm>
-            <a:off x="-3036722" y="-2936847"/>
-            <a:ext cx="6748272" cy="8637788"/>
+            <a:off x="777240" y="777240"/>
+            <a:ext cx="635508" cy="373380"/>
           </a:xfrm>
-          <a:prstGeom prst="ellipse">
-            <a:avLst/>
+          <a:prstGeom prst="roundRect">
+            <a:avLst>
+              <a:gd name="adj" fmla="val 50000"/>
+            </a:avLst>
           </a:prstGeom>
           <a:solidFill>
-            <a:srgbClr val="14181F">
-              <a:alpha val="16000"/>
-            </a:srgbClr>
+            <a:srgbClr val="14181F"/>
           </a:solidFill>
           <a:ln>
             <a:noFill/>
@@ -3849,10 +3999,19 @@
           </a:fontRef>
         </p:style>
         <p:txBody>
-          <a:bodyPr rtlCol="0" anchor="ctr"/>
+          <a:bodyPr rtlCol="0" anchor="ctr" wrap="none" lIns="128016" rIns="128016" tIns="18288" bIns="18288"/>
           <a:lstStyle/>
           <a:p>
             <a:pPr algn="ctr"/>
+            <a:r>
+              <a:rPr sz="1500" b="1">
+                <a:solidFill>
+                  <a:srgbClr val="F5C13F"/>
+                </a:solidFill>
+                <a:latin typeface="Bricolage Grotesque"/>
+              </a:rPr>
+              <a:t>TÚ</a:t>
+            </a:r>
           </a:p>
         </p:txBody>
       </p:sp>
@@ -3864,7 +4023,7 @@
         </p:nvSpPr>
         <p:spPr>
           <a:xfrm>
-            <a:off x="777240" y="1669161"/>
+            <a:off x="777240" y="1812036"/>
             <a:ext cx="1371600" cy="146304"/>
           </a:xfrm>
           <a:prstGeom prst="rect">
@@ -3908,8 +4067,8 @@
         </p:nvSpPr>
         <p:spPr>
           <a:xfrm>
-            <a:off x="777240" y="2126361"/>
-            <a:ext cx="6675120" cy="3245357"/>
+            <a:off x="777240" y="2269236"/>
+            <a:ext cx="6675120" cy="2959607"/>
           </a:xfrm>
           <a:prstGeom prst="rect">
             <a:avLst/>
@@ -3928,7 +4087,7 @@
               </a:lnSpc>
             </a:pPr>
             <a:r>
-              <a:rPr sz="6200" b="1">
+              <a:rPr sz="5600" b="1">
                 <a:solidFill>
                   <a:srgbClr val="14181F"/>
                 </a:solidFill>
@@ -3947,8 +4106,8 @@
         </p:nvSpPr>
         <p:spPr>
           <a:xfrm>
-            <a:off x="777240" y="5371718"/>
-            <a:ext cx="6675120" cy="1530858"/>
+            <a:off x="777240" y="6355081"/>
+            <a:ext cx="6675120" cy="822960"/>
           </a:xfrm>
           <a:prstGeom prst="rect">
             <a:avLst/>
@@ -3963,15 +4122,15 @@
           <a:p>
             <a:pPr algn="l">
               <a:lnSpc>
-                <a:spcPct val="110000"/>
+                <a:spcPct val="100000"/>
               </a:lnSpc>
             </a:pPr>
             <a:r>
-              <a:rPr sz="2600" b="0">
+              <a:rPr sz="2600" b="1">
                 <a:solidFill>
                   <a:srgbClr val="14181F"/>
                 </a:solidFill>
-                <a:latin typeface="Hanken Grotesk"/>
+                <a:latin typeface="Bricolage Grotesque"/>
               </a:rPr>
               <a:t>Comenta 👇 y pide los tuyos en huevera.cl</a:t>
             </a:r>

</xml_diff>